<commit_message>
Update team names on title slide
</commit_message>
<xml_diff>
--- a/AdPulse_Presentation.pptx
+++ b/AdPulse_Presentation.pptx
@@ -5,20 +5,20 @@
     <p:sldMasterId id="2147483648" r:id="rId1"/>
   </p:sldMasterIdLst>
   <p:sldIdLst>
-    <p:sldId id="256" r:id="rId7"/>
-    <p:sldId id="257" r:id="rId8"/>
-    <p:sldId id="258" r:id="rId9"/>
-    <p:sldId id="259" r:id="rId10"/>
-    <p:sldId id="260" r:id="rId11"/>
-    <p:sldId id="261" r:id="rId12"/>
-    <p:sldId id="262" r:id="rId13"/>
-    <p:sldId id="263" r:id="rId14"/>
-    <p:sldId id="264" r:id="rId15"/>
-    <p:sldId id="265" r:id="rId16"/>
-    <p:sldId id="266" r:id="rId17"/>
-    <p:sldId id="267" r:id="rId18"/>
+    <p:sldId id="256" r:id="rId2"/>
+    <p:sldId id="257" r:id="rId3"/>
+    <p:sldId id="258" r:id="rId4"/>
+    <p:sldId id="259" r:id="rId5"/>
+    <p:sldId id="260" r:id="rId6"/>
+    <p:sldId id="261" r:id="rId7"/>
+    <p:sldId id="262" r:id="rId8"/>
+    <p:sldId id="263" r:id="rId9"/>
+    <p:sldId id="264" r:id="rId10"/>
+    <p:sldId id="265" r:id="rId11"/>
+    <p:sldId id="266" r:id="rId12"/>
+    <p:sldId id="267" r:id="rId13"/>
   </p:sldIdLst>
-  <p:sldSz cx="12191695" cy="6858000" type="screen4x3"/>
+  <p:sldSz cx="12192000" cy="6858000"/>
   <p:notesSz cx="6858000" cy="9144000"/>
   <p:defaultTextStyle>
     <a:defPPr>
@@ -115,6 +115,22 @@
       </a:defRPr>
     </a:lvl9pPr>
   </p:defaultTextStyle>
+  <p:extLst>
+    <p:ext uri="{EFAFB233-063F-42B5-8137-9DF3F51BA10A}">
+      <p15:sldGuideLst xmlns:p15="http://schemas.microsoft.com/office/powerpoint/2012/main">
+        <p15:guide id="1" orient="horz" pos="2160">
+          <p15:clr>
+            <a:srgbClr val="A4A3A4"/>
+          </p15:clr>
+        </p15:guide>
+        <p15:guide id="2" pos="2880">
+          <p15:clr>
+            <a:srgbClr val="A4A3A4"/>
+          </p15:clr>
+        </p15:guide>
+      </p15:sldGuideLst>
+    </p:ext>
+  </p:extLst>
 </p:presentation>
 </file>
 
@@ -156,10 +172,9 @@
           <a:lstStyle/>
           <a:p>
             <a:r>
-              <a:rPr lang="en-US" smtClean="0"/>
+              <a:rPr lang="en-US"/>
               <a:t>Click to edit Master title style</a:t>
             </a:r>
-            <a:endParaRPr lang="en-US"/>
           </a:p>
         </p:txBody>
       </p:sp>
@@ -275,10 +290,9 @@
           </a:lstStyle>
           <a:p>
             <a:r>
-              <a:rPr lang="en-US" smtClean="0"/>
+              <a:rPr lang="en-US"/>
               <a:t>Click to edit Master subtitle style</a:t>
             </a:r>
-            <a:endParaRPr lang="en-US"/>
           </a:p>
         </p:txBody>
       </p:sp>
@@ -299,7 +313,7 @@
           <a:p>
             <a:fld id="{5BCAD085-E8A6-8845-BD4E-CB4CCA059FC4}" type="datetimeFigureOut">
               <a:rPr lang="en-US" smtClean="0"/>
-              <a:t>1/27/13</a:t>
+              <a:t>3/6/26</a:t>
             </a:fld>
             <a:endParaRPr lang="en-US"/>
           </a:p>
@@ -393,10 +407,9 @@
           <a:lstStyle/>
           <a:p>
             <a:r>
-              <a:rPr lang="en-US" smtClean="0"/>
+              <a:rPr lang="en-US"/>
               <a:t>Click to edit Master title style</a:t>
             </a:r>
-            <a:endParaRPr lang="en-US"/>
           </a:p>
         </p:txBody>
       </p:sp>
@@ -417,38 +430,37 @@
           <a:p>
             <a:pPr lvl="0"/>
             <a:r>
-              <a:rPr lang="en-US" smtClean="0"/>
+              <a:rPr lang="en-US"/>
               <a:t>Click to edit Master text styles</a:t>
             </a:r>
           </a:p>
           <a:p>
             <a:pPr lvl="1"/>
             <a:r>
-              <a:rPr lang="en-US" smtClean="0"/>
+              <a:rPr lang="en-US"/>
               <a:t>Second level</a:t>
             </a:r>
           </a:p>
           <a:p>
             <a:pPr lvl="2"/>
             <a:r>
-              <a:rPr lang="en-US" smtClean="0"/>
+              <a:rPr lang="en-US"/>
               <a:t>Third level</a:t>
             </a:r>
           </a:p>
           <a:p>
             <a:pPr lvl="3"/>
             <a:r>
-              <a:rPr lang="en-US" smtClean="0"/>
+              <a:rPr lang="en-US"/>
               <a:t>Fourth level</a:t>
             </a:r>
           </a:p>
           <a:p>
             <a:pPr lvl="4"/>
             <a:r>
-              <a:rPr lang="en-US" smtClean="0"/>
+              <a:rPr lang="en-US"/>
               <a:t>Fifth level</a:t>
             </a:r>
-            <a:endParaRPr lang="en-US"/>
           </a:p>
         </p:txBody>
       </p:sp>
@@ -469,7 +481,7 @@
           <a:p>
             <a:fld id="{5BCAD085-E8A6-8845-BD4E-CB4CCA059FC4}" type="datetimeFigureOut">
               <a:rPr lang="en-US" smtClean="0"/>
-              <a:t>1/27/13</a:t>
+              <a:t>3/6/26</a:t>
             </a:fld>
             <a:endParaRPr lang="en-US"/>
           </a:p>
@@ -568,10 +580,9 @@
           <a:lstStyle/>
           <a:p>
             <a:r>
-              <a:rPr lang="en-US" smtClean="0"/>
+              <a:rPr lang="en-US"/>
               <a:t>Click to edit Master title style</a:t>
             </a:r>
-            <a:endParaRPr lang="en-US"/>
           </a:p>
         </p:txBody>
       </p:sp>
@@ -597,38 +608,37 @@
           <a:p>
             <a:pPr lvl="0"/>
             <a:r>
-              <a:rPr lang="en-US" smtClean="0"/>
+              <a:rPr lang="en-US"/>
               <a:t>Click to edit Master text styles</a:t>
             </a:r>
           </a:p>
           <a:p>
             <a:pPr lvl="1"/>
             <a:r>
-              <a:rPr lang="en-US" smtClean="0"/>
+              <a:rPr lang="en-US"/>
               <a:t>Second level</a:t>
             </a:r>
           </a:p>
           <a:p>
             <a:pPr lvl="2"/>
             <a:r>
-              <a:rPr lang="en-US" smtClean="0"/>
+              <a:rPr lang="en-US"/>
               <a:t>Third level</a:t>
             </a:r>
           </a:p>
           <a:p>
             <a:pPr lvl="3"/>
             <a:r>
-              <a:rPr lang="en-US" smtClean="0"/>
+              <a:rPr lang="en-US"/>
               <a:t>Fourth level</a:t>
             </a:r>
           </a:p>
           <a:p>
             <a:pPr lvl="4"/>
             <a:r>
-              <a:rPr lang="en-US" smtClean="0"/>
+              <a:rPr lang="en-US"/>
               <a:t>Fifth level</a:t>
             </a:r>
-            <a:endParaRPr lang="en-US"/>
           </a:p>
         </p:txBody>
       </p:sp>
@@ -649,7 +659,7 @@
           <a:p>
             <a:fld id="{5BCAD085-E8A6-8845-BD4E-CB4CCA059FC4}" type="datetimeFigureOut">
               <a:rPr lang="en-US" smtClean="0"/>
-              <a:t>1/27/13</a:t>
+              <a:t>3/6/26</a:t>
             </a:fld>
             <a:endParaRPr lang="en-US"/>
           </a:p>
@@ -743,10 +753,9 @@
           <a:lstStyle/>
           <a:p>
             <a:r>
-              <a:rPr lang="en-US" smtClean="0"/>
+              <a:rPr lang="en-US"/>
               <a:t>Click to edit Master title style</a:t>
             </a:r>
-            <a:endParaRPr lang="en-US"/>
           </a:p>
         </p:txBody>
       </p:sp>
@@ -767,38 +776,37 @@
           <a:p>
             <a:pPr lvl="0"/>
             <a:r>
-              <a:rPr lang="en-US" smtClean="0"/>
+              <a:rPr lang="en-US"/>
               <a:t>Click to edit Master text styles</a:t>
             </a:r>
           </a:p>
           <a:p>
             <a:pPr lvl="1"/>
             <a:r>
-              <a:rPr lang="en-US" smtClean="0"/>
+              <a:rPr lang="en-US"/>
               <a:t>Second level</a:t>
             </a:r>
           </a:p>
           <a:p>
             <a:pPr lvl="2"/>
             <a:r>
-              <a:rPr lang="en-US" smtClean="0"/>
+              <a:rPr lang="en-US"/>
               <a:t>Third level</a:t>
             </a:r>
           </a:p>
           <a:p>
             <a:pPr lvl="3"/>
             <a:r>
-              <a:rPr lang="en-US" smtClean="0"/>
+              <a:rPr lang="en-US"/>
               <a:t>Fourth level</a:t>
             </a:r>
           </a:p>
           <a:p>
             <a:pPr lvl="4"/>
             <a:r>
-              <a:rPr lang="en-US" smtClean="0"/>
+              <a:rPr lang="en-US"/>
               <a:t>Fifth level</a:t>
             </a:r>
-            <a:endParaRPr lang="en-US"/>
           </a:p>
         </p:txBody>
       </p:sp>
@@ -819,7 +827,7 @@
           <a:p>
             <a:fld id="{5BCAD085-E8A6-8845-BD4E-CB4CCA059FC4}" type="datetimeFigureOut">
               <a:rPr lang="en-US" smtClean="0"/>
-              <a:t>1/27/13</a:t>
+              <a:t>3/6/26</a:t>
             </a:fld>
             <a:endParaRPr lang="en-US"/>
           </a:p>
@@ -922,10 +930,9 @@
           </a:lstStyle>
           <a:p>
             <a:r>
-              <a:rPr lang="en-US" smtClean="0"/>
+              <a:rPr lang="en-US"/>
               <a:t>Click to edit Master title style</a:t>
             </a:r>
-            <a:endParaRPr lang="en-US"/>
           </a:p>
         </p:txBody>
       </p:sp>
@@ -1042,7 +1049,7 @@
           <a:p>
             <a:pPr lvl="0"/>
             <a:r>
-              <a:rPr lang="en-US" smtClean="0"/>
+              <a:rPr lang="en-US"/>
               <a:t>Click to edit Master text styles</a:t>
             </a:r>
           </a:p>
@@ -1065,7 +1072,7 @@
           <a:p>
             <a:fld id="{5BCAD085-E8A6-8845-BD4E-CB4CCA059FC4}" type="datetimeFigureOut">
               <a:rPr lang="en-US" smtClean="0"/>
-              <a:t>1/27/13</a:t>
+              <a:t>3/6/26</a:t>
             </a:fld>
             <a:endParaRPr lang="en-US"/>
           </a:p>
@@ -1159,10 +1166,9 @@
           <a:lstStyle/>
           <a:p>
             <a:r>
-              <a:rPr lang="en-US" smtClean="0"/>
+              <a:rPr lang="en-US"/>
               <a:t>Click to edit Master title style</a:t>
             </a:r>
-            <a:endParaRPr lang="en-US"/>
           </a:p>
         </p:txBody>
       </p:sp>
@@ -1216,38 +1222,37 @@
           <a:p>
             <a:pPr lvl="0"/>
             <a:r>
-              <a:rPr lang="en-US" smtClean="0"/>
+              <a:rPr lang="en-US"/>
               <a:t>Click to edit Master text styles</a:t>
             </a:r>
           </a:p>
           <a:p>
             <a:pPr lvl="1"/>
             <a:r>
-              <a:rPr lang="en-US" smtClean="0"/>
+              <a:rPr lang="en-US"/>
               <a:t>Second level</a:t>
             </a:r>
           </a:p>
           <a:p>
             <a:pPr lvl="2"/>
             <a:r>
-              <a:rPr lang="en-US" smtClean="0"/>
+              <a:rPr lang="en-US"/>
               <a:t>Third level</a:t>
             </a:r>
           </a:p>
           <a:p>
             <a:pPr lvl="3"/>
             <a:r>
-              <a:rPr lang="en-US" smtClean="0"/>
+              <a:rPr lang="en-US"/>
               <a:t>Fourth level</a:t>
             </a:r>
           </a:p>
           <a:p>
             <a:pPr lvl="4"/>
             <a:r>
-              <a:rPr lang="en-US" smtClean="0"/>
+              <a:rPr lang="en-US"/>
               <a:t>Fifth level</a:t>
             </a:r>
-            <a:endParaRPr lang="en-US"/>
           </a:p>
         </p:txBody>
       </p:sp>
@@ -1301,38 +1306,37 @@
           <a:p>
             <a:pPr lvl="0"/>
             <a:r>
-              <a:rPr lang="en-US" smtClean="0"/>
+              <a:rPr lang="en-US"/>
               <a:t>Click to edit Master text styles</a:t>
             </a:r>
           </a:p>
           <a:p>
             <a:pPr lvl="1"/>
             <a:r>
-              <a:rPr lang="en-US" smtClean="0"/>
+              <a:rPr lang="en-US"/>
               <a:t>Second level</a:t>
             </a:r>
           </a:p>
           <a:p>
             <a:pPr lvl="2"/>
             <a:r>
-              <a:rPr lang="en-US" smtClean="0"/>
+              <a:rPr lang="en-US"/>
               <a:t>Third level</a:t>
             </a:r>
           </a:p>
           <a:p>
             <a:pPr lvl="3"/>
             <a:r>
-              <a:rPr lang="en-US" smtClean="0"/>
+              <a:rPr lang="en-US"/>
               <a:t>Fourth level</a:t>
             </a:r>
           </a:p>
           <a:p>
             <a:pPr lvl="4"/>
             <a:r>
-              <a:rPr lang="en-US" smtClean="0"/>
+              <a:rPr lang="en-US"/>
               <a:t>Fifth level</a:t>
             </a:r>
-            <a:endParaRPr lang="en-US"/>
           </a:p>
         </p:txBody>
       </p:sp>
@@ -1353,7 +1357,7 @@
           <a:p>
             <a:fld id="{5BCAD085-E8A6-8845-BD4E-CB4CCA059FC4}" type="datetimeFigureOut">
               <a:rPr lang="en-US" smtClean="0"/>
-              <a:t>1/27/13</a:t>
+              <a:t>3/6/26</a:t>
             </a:fld>
             <a:endParaRPr lang="en-US"/>
           </a:p>
@@ -1451,10 +1455,9 @@
           </a:lstStyle>
           <a:p>
             <a:r>
-              <a:rPr lang="en-US" smtClean="0"/>
+              <a:rPr lang="en-US"/>
               <a:t>Click to edit Master title style</a:t>
             </a:r>
-            <a:endParaRPr lang="en-US"/>
           </a:p>
         </p:txBody>
       </p:sp>
@@ -1517,7 +1520,7 @@
           <a:p>
             <a:pPr lvl="0"/>
             <a:r>
-              <a:rPr lang="en-US" smtClean="0"/>
+              <a:rPr lang="en-US"/>
               <a:t>Click to edit Master text styles</a:t>
             </a:r>
           </a:p>
@@ -1573,38 +1576,37 @@
           <a:p>
             <a:pPr lvl="0"/>
             <a:r>
-              <a:rPr lang="en-US" smtClean="0"/>
+              <a:rPr lang="en-US"/>
               <a:t>Click to edit Master text styles</a:t>
             </a:r>
           </a:p>
           <a:p>
             <a:pPr lvl="1"/>
             <a:r>
-              <a:rPr lang="en-US" smtClean="0"/>
+              <a:rPr lang="en-US"/>
               <a:t>Second level</a:t>
             </a:r>
           </a:p>
           <a:p>
             <a:pPr lvl="2"/>
             <a:r>
-              <a:rPr lang="en-US" smtClean="0"/>
+              <a:rPr lang="en-US"/>
               <a:t>Third level</a:t>
             </a:r>
           </a:p>
           <a:p>
             <a:pPr lvl="3"/>
             <a:r>
-              <a:rPr lang="en-US" smtClean="0"/>
+              <a:rPr lang="en-US"/>
               <a:t>Fourth level</a:t>
             </a:r>
           </a:p>
           <a:p>
             <a:pPr lvl="4"/>
             <a:r>
-              <a:rPr lang="en-US" smtClean="0"/>
+              <a:rPr lang="en-US"/>
               <a:t>Fifth level</a:t>
             </a:r>
-            <a:endParaRPr lang="en-US"/>
           </a:p>
         </p:txBody>
       </p:sp>
@@ -1667,7 +1669,7 @@
           <a:p>
             <a:pPr lvl="0"/>
             <a:r>
-              <a:rPr lang="en-US" smtClean="0"/>
+              <a:rPr lang="en-US"/>
               <a:t>Click to edit Master text styles</a:t>
             </a:r>
           </a:p>
@@ -1723,38 +1725,37 @@
           <a:p>
             <a:pPr lvl="0"/>
             <a:r>
-              <a:rPr lang="en-US" smtClean="0"/>
+              <a:rPr lang="en-US"/>
               <a:t>Click to edit Master text styles</a:t>
             </a:r>
           </a:p>
           <a:p>
             <a:pPr lvl="1"/>
             <a:r>
-              <a:rPr lang="en-US" smtClean="0"/>
+              <a:rPr lang="en-US"/>
               <a:t>Second level</a:t>
             </a:r>
           </a:p>
           <a:p>
             <a:pPr lvl="2"/>
             <a:r>
-              <a:rPr lang="en-US" smtClean="0"/>
+              <a:rPr lang="en-US"/>
               <a:t>Third level</a:t>
             </a:r>
           </a:p>
           <a:p>
             <a:pPr lvl="3"/>
             <a:r>
-              <a:rPr lang="en-US" smtClean="0"/>
+              <a:rPr lang="en-US"/>
               <a:t>Fourth level</a:t>
             </a:r>
           </a:p>
           <a:p>
             <a:pPr lvl="4"/>
             <a:r>
-              <a:rPr lang="en-US" smtClean="0"/>
+              <a:rPr lang="en-US"/>
               <a:t>Fifth level</a:t>
             </a:r>
-            <a:endParaRPr lang="en-US"/>
           </a:p>
         </p:txBody>
       </p:sp>
@@ -1775,7 +1776,7 @@
           <a:p>
             <a:fld id="{5BCAD085-E8A6-8845-BD4E-CB4CCA059FC4}" type="datetimeFigureOut">
               <a:rPr lang="en-US" smtClean="0"/>
-              <a:t>1/27/13</a:t>
+              <a:t>3/6/26</a:t>
             </a:fld>
             <a:endParaRPr lang="en-US"/>
           </a:p>
@@ -1869,10 +1870,9 @@
           <a:lstStyle/>
           <a:p>
             <a:r>
-              <a:rPr lang="en-US" smtClean="0"/>
+              <a:rPr lang="en-US"/>
               <a:t>Click to edit Master title style</a:t>
             </a:r>
-            <a:endParaRPr lang="en-US"/>
           </a:p>
         </p:txBody>
       </p:sp>
@@ -1893,7 +1893,7 @@
           <a:p>
             <a:fld id="{5BCAD085-E8A6-8845-BD4E-CB4CCA059FC4}" type="datetimeFigureOut">
               <a:rPr lang="en-US" smtClean="0"/>
-              <a:t>1/27/13</a:t>
+              <a:t>3/6/26</a:t>
             </a:fld>
             <a:endParaRPr lang="en-US"/>
           </a:p>
@@ -1988,7 +1988,7 @@
           <a:p>
             <a:fld id="{5BCAD085-E8A6-8845-BD4E-CB4CCA059FC4}" type="datetimeFigureOut">
               <a:rPr lang="en-US" smtClean="0"/>
-              <a:t>1/27/13</a:t>
+              <a:t>3/6/26</a:t>
             </a:fld>
             <a:endParaRPr lang="en-US"/>
           </a:p>
@@ -2091,10 +2091,9 @@
           </a:lstStyle>
           <a:p>
             <a:r>
-              <a:rPr lang="en-US" smtClean="0"/>
+              <a:rPr lang="en-US"/>
               <a:t>Click to edit Master title style</a:t>
             </a:r>
-            <a:endParaRPr lang="en-US"/>
           </a:p>
         </p:txBody>
       </p:sp>
@@ -2148,38 +2147,37 @@
           <a:p>
             <a:pPr lvl="0"/>
             <a:r>
-              <a:rPr lang="en-US" smtClean="0"/>
+              <a:rPr lang="en-US"/>
               <a:t>Click to edit Master text styles</a:t>
             </a:r>
           </a:p>
           <a:p>
             <a:pPr lvl="1"/>
             <a:r>
-              <a:rPr lang="en-US" smtClean="0"/>
+              <a:rPr lang="en-US"/>
               <a:t>Second level</a:t>
             </a:r>
           </a:p>
           <a:p>
             <a:pPr lvl="2"/>
             <a:r>
-              <a:rPr lang="en-US" smtClean="0"/>
+              <a:rPr lang="en-US"/>
               <a:t>Third level</a:t>
             </a:r>
           </a:p>
           <a:p>
             <a:pPr lvl="3"/>
             <a:r>
-              <a:rPr lang="en-US" smtClean="0"/>
+              <a:rPr lang="en-US"/>
               <a:t>Fourth level</a:t>
             </a:r>
           </a:p>
           <a:p>
             <a:pPr lvl="4"/>
             <a:r>
-              <a:rPr lang="en-US" smtClean="0"/>
+              <a:rPr lang="en-US"/>
               <a:t>Fifth level</a:t>
             </a:r>
-            <a:endParaRPr lang="en-US"/>
           </a:p>
         </p:txBody>
       </p:sp>
@@ -2242,7 +2240,7 @@
           <a:p>
             <a:pPr lvl="0"/>
             <a:r>
-              <a:rPr lang="en-US" smtClean="0"/>
+              <a:rPr lang="en-US"/>
               <a:t>Click to edit Master text styles</a:t>
             </a:r>
           </a:p>
@@ -2265,7 +2263,7 @@
           <a:p>
             <a:fld id="{5BCAD085-E8A6-8845-BD4E-CB4CCA059FC4}" type="datetimeFigureOut">
               <a:rPr lang="en-US" smtClean="0"/>
-              <a:t>1/27/13</a:t>
+              <a:t>3/6/26</a:t>
             </a:fld>
             <a:endParaRPr lang="en-US"/>
           </a:p>
@@ -2368,10 +2366,9 @@
           </a:lstStyle>
           <a:p>
             <a:r>
-              <a:rPr lang="en-US" smtClean="0"/>
+              <a:rPr lang="en-US"/>
               <a:t>Click to edit Master title style</a:t>
             </a:r>
-            <a:endParaRPr lang="en-US"/>
           </a:p>
         </p:txBody>
       </p:sp>
@@ -2495,7 +2492,7 @@
           <a:p>
             <a:pPr lvl="0"/>
             <a:r>
-              <a:rPr lang="en-US" smtClean="0"/>
+              <a:rPr lang="en-US"/>
               <a:t>Click to edit Master text styles</a:t>
             </a:r>
           </a:p>
@@ -2518,7 +2515,7 @@
           <a:p>
             <a:fld id="{5BCAD085-E8A6-8845-BD4E-CB4CCA059FC4}" type="datetimeFigureOut">
               <a:rPr lang="en-US" smtClean="0"/>
-              <a:t>1/27/13</a:t>
+              <a:t>3/6/26</a:t>
             </a:fld>
             <a:endParaRPr lang="en-US"/>
           </a:p>
@@ -2627,10 +2624,9 @@
           <a:lstStyle/>
           <a:p>
             <a:r>
-              <a:rPr lang="en-US" smtClean="0"/>
+              <a:rPr lang="en-US"/>
               <a:t>Click to edit Master title style</a:t>
             </a:r>
-            <a:endParaRPr lang="en-US"/>
           </a:p>
         </p:txBody>
       </p:sp>
@@ -2661,38 +2657,37 @@
           <a:p>
             <a:pPr lvl="0"/>
             <a:r>
-              <a:rPr lang="en-US" smtClean="0"/>
+              <a:rPr lang="en-US"/>
               <a:t>Click to edit Master text styles</a:t>
             </a:r>
           </a:p>
           <a:p>
             <a:pPr lvl="1"/>
             <a:r>
-              <a:rPr lang="en-US" smtClean="0"/>
+              <a:rPr lang="en-US"/>
               <a:t>Second level</a:t>
             </a:r>
           </a:p>
           <a:p>
             <a:pPr lvl="2"/>
             <a:r>
-              <a:rPr lang="en-US" smtClean="0"/>
+              <a:rPr lang="en-US"/>
               <a:t>Third level</a:t>
             </a:r>
           </a:p>
           <a:p>
             <a:pPr lvl="3"/>
             <a:r>
-              <a:rPr lang="en-US" smtClean="0"/>
+              <a:rPr lang="en-US"/>
               <a:t>Fourth level</a:t>
             </a:r>
           </a:p>
           <a:p>
             <a:pPr lvl="4"/>
             <a:r>
-              <a:rPr lang="en-US" smtClean="0"/>
+              <a:rPr lang="en-US"/>
               <a:t>Fifth level</a:t>
             </a:r>
-            <a:endParaRPr lang="en-US"/>
           </a:p>
         </p:txBody>
       </p:sp>
@@ -2731,7 +2726,7 @@
           <a:p>
             <a:fld id="{5BCAD085-E8A6-8845-BD4E-CB4CCA059FC4}" type="datetimeFigureOut">
               <a:rPr lang="en-US" smtClean="0"/>
-              <a:t>1/27/13</a:t>
+              <a:t>3/6/26</a:t>
             </a:fld>
             <a:endParaRPr lang="en-US"/>
           </a:p>
@@ -3090,7 +3085,7 @@
 </file>
 
 <file path=ppt/slides/slide1.xml><?xml version="1.0" encoding="utf-8"?>
-<p:sld xmlns:a="http://schemas.openxmlformats.org/drawingml/2006/main" xmlns:p="http://schemas.openxmlformats.org/presentationml/2006/main" xmlns:r="http://schemas.openxmlformats.org/officeDocument/2006/relationships">
+<p:sld xmlns:a="http://schemas.openxmlformats.org/drawingml/2006/main" xmlns:r="http://schemas.openxmlformats.org/officeDocument/2006/relationships" xmlns:p="http://schemas.openxmlformats.org/presentationml/2006/main">
   <p:cSld>
     <p:bg>
       <p:bgPr>
@@ -3106,7 +3101,14 @@
         <p:cNvGrpSpPr/>
         <p:nvPr/>
       </p:nvGrpSpPr>
-      <p:grpSpPr/>
+      <p:grpSpPr>
+        <a:xfrm>
+          <a:off x="0" y="0"/>
+          <a:ext cx="0" cy="0"/>
+          <a:chOff x="0" y="0"/>
+          <a:chExt cx="0" cy="0"/>
+        </a:xfrm>
+      </p:grpSpPr>
       <p:sp>
         <p:nvSpPr>
           <p:cNvPr id="2" name="Rectangle 1"/>
@@ -3147,6 +3149,7 @@
           <a:lstStyle/>
           <a:p>
             <a:pPr algn="ctr"/>
+            <a:endParaRPr/>
           </a:p>
         </p:txBody>
       </p:sp>
@@ -3258,6 +3261,7 @@
           <a:lstStyle/>
           <a:p>
             <a:pPr algn="ctr"/>
+            <a:endParaRPr/>
           </a:p>
         </p:txBody>
       </p:sp>
@@ -3358,7 +3362,24 @@
               </a:defRPr>
             </a:pPr>
             <a:r>
-              <a:t>Team: [Your Names Here]</a:t>
+              <a:rPr dirty="0"/>
+              <a:t>Team</a:t>
+            </a:r>
+            <a:r>
+              <a:rPr lang="en-US" dirty="0"/>
+              <a:t> 6</a:t>
+            </a:r>
+            <a:r>
+              <a:rPr dirty="0"/>
+              <a:t>: [</a:t>
+            </a:r>
+            <a:r>
+              <a:rPr lang="en-US" dirty="0"/>
+              <a:t>Graeme T Ampeire, Soumya Thareja, Tiffany Nakamitsu, Akanksha Singh</a:t>
+            </a:r>
+            <a:r>
+              <a:rPr dirty="0"/>
+              <a:t>]</a:t>
             </a:r>
           </a:p>
         </p:txBody>
@@ -3372,7 +3393,7 @@
 </file>
 
 <file path=ppt/slides/slide10.xml><?xml version="1.0" encoding="utf-8"?>
-<p:sld xmlns:a="http://schemas.openxmlformats.org/drawingml/2006/main" xmlns:p="http://schemas.openxmlformats.org/presentationml/2006/main" xmlns:r="http://schemas.openxmlformats.org/officeDocument/2006/relationships">
+<p:sld xmlns:a="http://schemas.openxmlformats.org/drawingml/2006/main" xmlns:r="http://schemas.openxmlformats.org/officeDocument/2006/relationships" xmlns:p="http://schemas.openxmlformats.org/presentationml/2006/main">
   <p:cSld>
     <p:bg>
       <p:bgPr>
@@ -3388,7 +3409,14 @@
         <p:cNvGrpSpPr/>
         <p:nvPr/>
       </p:nvGrpSpPr>
-      <p:grpSpPr/>
+      <p:grpSpPr>
+        <a:xfrm>
+          <a:off x="0" y="0"/>
+          <a:ext cx="0" cy="0"/>
+          <a:chOff x="0" y="0"/>
+          <a:chExt cx="0" cy="0"/>
+        </a:xfrm>
+      </p:grpSpPr>
       <p:sp>
         <p:nvSpPr>
           <p:cNvPr id="2" name="Rectangle 1"/>
@@ -3429,6 +3457,7 @@
           <a:lstStyle/>
           <a:p>
             <a:pPr algn="ctr"/>
+            <a:endParaRPr/>
           </a:p>
         </p:txBody>
       </p:sp>
@@ -3441,7 +3470,7 @@
         <p:spPr>
           <a:xfrm>
             <a:off x="731520" y="457200"/>
-            <a:ext cx="10058400" cy="548640"/>
+            <a:ext cx="10058400" cy="731520"/>
           </a:xfrm>
           <a:prstGeom prst="rect">
             <a:avLst/>
@@ -3474,7 +3503,7 @@
         </p:nvSpPr>
         <p:spPr>
           <a:xfrm>
-            <a:off x="731520" y="1051560"/>
+            <a:off x="731520" y="1097280"/>
             <a:ext cx="10058400" cy="457200"/>
           </a:xfrm>
           <a:prstGeom prst="rect">
@@ -3566,7 +3595,6 @@
                 </a:solidFill>
                 <a:latin typeface="Calibri"/>
               </a:defRPr>
-              <a:buChar char="•"/>
             </a:pPr>
             <a:r>
               <a:t>Upload any campaign CSV via the built-in Upload page</a:t>
@@ -3583,7 +3611,6 @@
                 </a:solidFill>
                 <a:latin typeface="Calibri"/>
               </a:defRPr>
-              <a:buChar char="•"/>
             </a:pPr>
             <a:r>
               <a:t>Automatic column detection for engagement metrics and text fields</a:t>
@@ -3600,7 +3627,6 @@
                 </a:solidFill>
                 <a:latin typeface="Calibri"/>
               </a:defRPr>
-              <a:buChar char="•"/>
             </a:pPr>
             <a:r>
               <a:t>Sentiment and topic analysis on any text data</a:t>
@@ -3617,7 +3643,6 @@
                 </a:solidFill>
                 <a:latin typeface="Calibri"/>
               </a:defRPr>
-              <a:buChar char="•"/>
             </a:pPr>
             <a:r>
               <a:t>Google Trends integration works for any brand name</a:t>
@@ -3634,7 +3659,6 @@
                 </a:solidFill>
                 <a:latin typeface="Calibri"/>
               </a:defRPr>
-              <a:buChar char="•"/>
             </a:pPr>
             <a:r>
               <a:t>YouTube comment fetcher works for any video URL</a:t>
@@ -3716,6 +3740,7 @@
           <a:lstStyle/>
           <a:p>
             <a:pPr algn="ctr"/>
+            <a:endParaRPr/>
           </a:p>
         </p:txBody>
       </p:sp>
@@ -3759,6 +3784,7 @@
           <a:lstStyle/>
           <a:p>
             <a:pPr algn="ctr"/>
+            <a:endParaRPr/>
           </a:p>
         </p:txBody>
       </p:sp>
@@ -3870,6 +3896,7 @@
           <a:lstStyle/>
           <a:p>
             <a:pPr algn="ctr"/>
+            <a:endParaRPr/>
           </a:p>
         </p:txBody>
       </p:sp>
@@ -3913,6 +3940,7 @@
           <a:lstStyle/>
           <a:p>
             <a:pPr algn="ctr"/>
+            <a:endParaRPr/>
           </a:p>
         </p:txBody>
       </p:sp>
@@ -4024,6 +4052,7 @@
           <a:lstStyle/>
           <a:p>
             <a:pPr algn="ctr"/>
+            <a:endParaRPr/>
           </a:p>
         </p:txBody>
       </p:sp>
@@ -4067,6 +4096,7 @@
           <a:lstStyle/>
           <a:p>
             <a:pPr algn="ctr"/>
+            <a:endParaRPr/>
           </a:p>
         </p:txBody>
       </p:sp>
@@ -4178,6 +4208,7 @@
           <a:lstStyle/>
           <a:p>
             <a:pPr algn="ctr"/>
+            <a:endParaRPr/>
           </a:p>
         </p:txBody>
       </p:sp>
@@ -4221,6 +4252,7 @@
           <a:lstStyle/>
           <a:p>
             <a:pPr algn="ctr"/>
+            <a:endParaRPr/>
           </a:p>
         </p:txBody>
       </p:sp>
@@ -4301,7 +4333,7 @@
 </file>
 
 <file path=ppt/slides/slide11.xml><?xml version="1.0" encoding="utf-8"?>
-<p:sld xmlns:a="http://schemas.openxmlformats.org/drawingml/2006/main" xmlns:p="http://schemas.openxmlformats.org/presentationml/2006/main" xmlns:r="http://schemas.openxmlformats.org/officeDocument/2006/relationships">
+<p:sld xmlns:a="http://schemas.openxmlformats.org/drawingml/2006/main" xmlns:r="http://schemas.openxmlformats.org/officeDocument/2006/relationships" xmlns:p="http://schemas.openxmlformats.org/presentationml/2006/main">
   <p:cSld>
     <p:bg>
       <p:bgPr>
@@ -4317,7 +4349,14 @@
         <p:cNvGrpSpPr/>
         <p:nvPr/>
       </p:nvGrpSpPr>
-      <p:grpSpPr/>
+      <p:grpSpPr>
+        <a:xfrm>
+          <a:off x="0" y="0"/>
+          <a:ext cx="0" cy="0"/>
+          <a:chOff x="0" y="0"/>
+          <a:chExt cx="0" cy="0"/>
+        </a:xfrm>
+      </p:grpSpPr>
       <p:sp>
         <p:nvSpPr>
           <p:cNvPr id="2" name="Rectangle 1"/>
@@ -4358,6 +4397,7 @@
           <a:lstStyle/>
           <a:p>
             <a:pPr algn="ctr"/>
+            <a:endParaRPr/>
           </a:p>
         </p:txBody>
       </p:sp>
@@ -4469,6 +4509,7 @@
           <a:lstStyle/>
           <a:p>
             <a:pPr algn="ctr"/>
+            <a:endParaRPr/>
           </a:p>
         </p:txBody>
       </p:sp>
@@ -4515,7 +4556,7 @@
 </file>
 
 <file path=ppt/slides/slide12.xml><?xml version="1.0" encoding="utf-8"?>
-<p:sld xmlns:a="http://schemas.openxmlformats.org/drawingml/2006/main" xmlns:p="http://schemas.openxmlformats.org/presentationml/2006/main" xmlns:r="http://schemas.openxmlformats.org/officeDocument/2006/relationships">
+<p:sld xmlns:a="http://schemas.openxmlformats.org/drawingml/2006/main" xmlns:r="http://schemas.openxmlformats.org/officeDocument/2006/relationships" xmlns:p="http://schemas.openxmlformats.org/presentationml/2006/main">
   <p:cSld>
     <p:bg>
       <p:bgPr>
@@ -4531,7 +4572,14 @@
         <p:cNvGrpSpPr/>
         <p:nvPr/>
       </p:nvGrpSpPr>
-      <p:grpSpPr/>
+      <p:grpSpPr>
+        <a:xfrm>
+          <a:off x="0" y="0"/>
+          <a:ext cx="0" cy="0"/>
+          <a:chOff x="0" y="0"/>
+          <a:chExt cx="0" cy="0"/>
+        </a:xfrm>
+      </p:grpSpPr>
       <p:sp>
         <p:nvSpPr>
           <p:cNvPr id="2" name="Rectangle 1"/>
@@ -4572,6 +4620,7 @@
           <a:lstStyle/>
           <a:p>
             <a:pPr algn="ctr"/>
+            <a:endParaRPr/>
           </a:p>
         </p:txBody>
       </p:sp>
@@ -4683,6 +4732,7 @@
           <a:lstStyle/>
           <a:p>
             <a:pPr algn="ctr"/>
+            <a:endParaRPr/>
           </a:p>
         </p:txBody>
       </p:sp>
@@ -4749,7 +4799,16 @@
               </a:defRPr>
             </a:pPr>
             <a:r>
-              <a:t>MSIS 521  —  Winter 2025  —  University of Washington</a:t>
+              <a:rPr dirty="0"/>
+              <a:t>MSIS 521  —  </a:t>
+            </a:r>
+            <a:r>
+              <a:rPr lang="en-US" dirty="0"/>
+              <a:t>Team 6 Purple Cohort </a:t>
+            </a:r>
+            <a:r>
+              <a:rPr dirty="0"/>
+              <a:t>—  University of Washington</a:t>
             </a:r>
           </a:p>
         </p:txBody>
@@ -4763,7 +4822,7 @@
 </file>
 
 <file path=ppt/slides/slide2.xml><?xml version="1.0" encoding="utf-8"?>
-<p:sld xmlns:a="http://schemas.openxmlformats.org/drawingml/2006/main" xmlns:p="http://schemas.openxmlformats.org/presentationml/2006/main" xmlns:r="http://schemas.openxmlformats.org/officeDocument/2006/relationships">
+<p:sld xmlns:a="http://schemas.openxmlformats.org/drawingml/2006/main" xmlns:r="http://schemas.openxmlformats.org/officeDocument/2006/relationships" xmlns:p="http://schemas.openxmlformats.org/presentationml/2006/main">
   <p:cSld>
     <p:bg>
       <p:bgPr>
@@ -4779,7 +4838,14 @@
         <p:cNvGrpSpPr/>
         <p:nvPr/>
       </p:nvGrpSpPr>
-      <p:grpSpPr/>
+      <p:grpSpPr>
+        <a:xfrm>
+          <a:off x="0" y="0"/>
+          <a:ext cx="0" cy="0"/>
+          <a:chOff x="0" y="0"/>
+          <a:chExt cx="0" cy="0"/>
+        </a:xfrm>
+      </p:grpSpPr>
       <p:sp>
         <p:nvSpPr>
           <p:cNvPr id="2" name="Rectangle 1"/>
@@ -4820,6 +4886,7 @@
           <a:lstStyle/>
           <a:p>
             <a:pPr algn="ctr"/>
+            <a:endParaRPr/>
           </a:p>
         </p:txBody>
       </p:sp>
@@ -4832,7 +4899,7 @@
         <p:spPr>
           <a:xfrm>
             <a:off x="731520" y="457200"/>
-            <a:ext cx="10058400" cy="548640"/>
+            <a:ext cx="10058400" cy="731520"/>
           </a:xfrm>
           <a:prstGeom prst="rect">
             <a:avLst/>
@@ -4865,7 +4932,7 @@
         </p:nvSpPr>
         <p:spPr>
           <a:xfrm>
-            <a:off x="731520" y="1051560"/>
+            <a:off x="731520" y="1097280"/>
             <a:ext cx="10058400" cy="457200"/>
           </a:xfrm>
           <a:prstGeom prst="rect">
@@ -4931,6 +4998,7 @@
           <a:lstStyle/>
           <a:p>
             <a:pPr algn="ctr"/>
+            <a:endParaRPr/>
           </a:p>
         </p:txBody>
       </p:sp>
@@ -5046,6 +5114,7 @@
           <a:lstStyle/>
           <a:p>
             <a:pPr algn="ctr"/>
+            <a:endParaRPr/>
           </a:p>
         </p:txBody>
       </p:sp>
@@ -5161,6 +5230,7 @@
           <a:lstStyle/>
           <a:p>
             <a:pPr algn="ctr"/>
+            <a:endParaRPr/>
           </a:p>
         </p:txBody>
       </p:sp>
@@ -5268,7 +5338,6 @@
                 </a:solidFill>
                 <a:latin typeface="Calibri"/>
               </a:defRPr>
-              <a:buChar char="•"/>
             </a:pPr>
             <a:r>
               <a:t>Brands invest millions but rely on subjective measures of ad success</a:t>
@@ -5285,7 +5354,6 @@
                 </a:solidFill>
                 <a:latin typeface="Calibri"/>
               </a:defRPr>
-              <a:buChar char="•"/>
             </a:pPr>
             <a:r>
               <a:t>Traditional metrics (TV ratings, reach) miss the digital conversation</a:t>
@@ -5302,7 +5370,6 @@
                 </a:solidFill>
                 <a:latin typeface="Calibri"/>
               </a:defRPr>
-              <a:buChar char="•"/>
             </a:pPr>
             <a:r>
               <a:t>No unified tool to analyze engagement, sentiment, and themes at scale</a:t>
@@ -5319,7 +5386,6 @@
                 </a:solidFill>
                 <a:latin typeface="Calibri"/>
               </a:defRPr>
-              <a:buChar char="•"/>
             </a:pPr>
             <a:r>
               <a:t>Marketers need data-driven insights to optimize future campaigns</a:t>
@@ -5336,7 +5402,7 @@
 </file>
 
 <file path=ppt/slides/slide3.xml><?xml version="1.0" encoding="utf-8"?>
-<p:sld xmlns:a="http://schemas.openxmlformats.org/drawingml/2006/main" xmlns:p="http://schemas.openxmlformats.org/presentationml/2006/main" xmlns:r="http://schemas.openxmlformats.org/officeDocument/2006/relationships">
+<p:sld xmlns:a="http://schemas.openxmlformats.org/drawingml/2006/main" xmlns:r="http://schemas.openxmlformats.org/officeDocument/2006/relationships" xmlns:p="http://schemas.openxmlformats.org/presentationml/2006/main">
   <p:cSld>
     <p:bg>
       <p:bgPr>
@@ -5352,7 +5418,14 @@
         <p:cNvGrpSpPr/>
         <p:nvPr/>
       </p:nvGrpSpPr>
-      <p:grpSpPr/>
+      <p:grpSpPr>
+        <a:xfrm>
+          <a:off x="0" y="0"/>
+          <a:ext cx="0" cy="0"/>
+          <a:chOff x="0" y="0"/>
+          <a:chExt cx="0" cy="0"/>
+        </a:xfrm>
+      </p:grpSpPr>
       <p:sp>
         <p:nvSpPr>
           <p:cNvPr id="2" name="Rectangle 1"/>
@@ -5393,6 +5466,7 @@
           <a:lstStyle/>
           <a:p>
             <a:pPr algn="ctr"/>
+            <a:endParaRPr/>
           </a:p>
         </p:txBody>
       </p:sp>
@@ -5405,7 +5479,7 @@
         <p:spPr>
           <a:xfrm>
             <a:off x="731520" y="457200"/>
-            <a:ext cx="10058400" cy="548640"/>
+            <a:ext cx="10058400" cy="731520"/>
           </a:xfrm>
           <a:prstGeom prst="rect">
             <a:avLst/>
@@ -5438,7 +5512,7 @@
         </p:nvSpPr>
         <p:spPr>
           <a:xfrm>
-            <a:off x="731520" y="1051560"/>
+            <a:off x="731520" y="1097280"/>
             <a:ext cx="10058400" cy="457200"/>
           </a:xfrm>
           <a:prstGeom prst="rect">
@@ -5504,6 +5578,7 @@
           <a:lstStyle/>
           <a:p>
             <a:pPr algn="ctr"/>
+            <a:endParaRPr/>
           </a:p>
         </p:txBody>
       </p:sp>
@@ -5547,6 +5622,7 @@
           <a:lstStyle/>
           <a:p>
             <a:pPr algn="ctr"/>
+            <a:endParaRPr/>
           </a:p>
         </p:txBody>
       </p:sp>
@@ -5662,6 +5738,7 @@
           <a:lstStyle/>
           <a:p>
             <a:pPr algn="ctr"/>
+            <a:endParaRPr/>
           </a:p>
         </p:txBody>
       </p:sp>
@@ -5705,6 +5782,7 @@
           <a:lstStyle/>
           <a:p>
             <a:pPr algn="ctr"/>
+            <a:endParaRPr/>
           </a:p>
         </p:txBody>
       </p:sp>
@@ -5820,6 +5898,7 @@
           <a:lstStyle/>
           <a:p>
             <a:pPr algn="ctr"/>
+            <a:endParaRPr/>
           </a:p>
         </p:txBody>
       </p:sp>
@@ -5863,6 +5942,7 @@
           <a:lstStyle/>
           <a:p>
             <a:pPr algn="ctr"/>
+            <a:endParaRPr/>
           </a:p>
         </p:txBody>
       </p:sp>
@@ -5978,6 +6058,7 @@
           <a:lstStyle/>
           <a:p>
             <a:pPr algn="ctr"/>
+            <a:endParaRPr/>
           </a:p>
         </p:txBody>
       </p:sp>
@@ -6021,6 +6102,7 @@
           <a:lstStyle/>
           <a:p>
             <a:pPr algn="ctr"/>
+            <a:endParaRPr/>
           </a:p>
         </p:txBody>
       </p:sp>
@@ -6136,6 +6218,7 @@
           <a:lstStyle/>
           <a:p>
             <a:pPr algn="ctr"/>
+            <a:endParaRPr/>
           </a:p>
         </p:txBody>
       </p:sp>
@@ -6179,6 +6262,7 @@
           <a:lstStyle/>
           <a:p>
             <a:pPr algn="ctr"/>
+            <a:endParaRPr/>
           </a:p>
         </p:txBody>
       </p:sp>
@@ -6294,6 +6378,7 @@
           <a:lstStyle/>
           <a:p>
             <a:pPr algn="ctr"/>
+            <a:endParaRPr/>
           </a:p>
         </p:txBody>
       </p:sp>
@@ -6337,6 +6422,7 @@
           <a:lstStyle/>
           <a:p>
             <a:pPr algn="ctr"/>
+            <a:endParaRPr/>
           </a:p>
         </p:txBody>
       </p:sp>
@@ -6421,7 +6507,7 @@
 </file>
 
 <file path=ppt/slides/slide4.xml><?xml version="1.0" encoding="utf-8"?>
-<p:sld xmlns:a="http://schemas.openxmlformats.org/drawingml/2006/main" xmlns:p="http://schemas.openxmlformats.org/presentationml/2006/main" xmlns:r="http://schemas.openxmlformats.org/officeDocument/2006/relationships">
+<p:sld xmlns:a="http://schemas.openxmlformats.org/drawingml/2006/main" xmlns:r="http://schemas.openxmlformats.org/officeDocument/2006/relationships" xmlns:p="http://schemas.openxmlformats.org/presentationml/2006/main">
   <p:cSld>
     <p:bg>
       <p:bgPr>
@@ -6437,7 +6523,14 @@
         <p:cNvGrpSpPr/>
         <p:nvPr/>
       </p:nvGrpSpPr>
-      <p:grpSpPr/>
+      <p:grpSpPr>
+        <a:xfrm>
+          <a:off x="0" y="0"/>
+          <a:ext cx="0" cy="0"/>
+          <a:chOff x="0" y="0"/>
+          <a:chExt cx="0" cy="0"/>
+        </a:xfrm>
+      </p:grpSpPr>
       <p:sp>
         <p:nvSpPr>
           <p:cNvPr id="2" name="Rectangle 1"/>
@@ -6478,6 +6571,7 @@
           <a:lstStyle/>
           <a:p>
             <a:pPr algn="ctr"/>
+            <a:endParaRPr/>
           </a:p>
         </p:txBody>
       </p:sp>
@@ -6490,7 +6584,7 @@
         <p:spPr>
           <a:xfrm>
             <a:off x="731520" y="457200"/>
-            <a:ext cx="10058400" cy="548640"/>
+            <a:ext cx="10058400" cy="731520"/>
           </a:xfrm>
           <a:prstGeom prst="rect">
             <a:avLst/>
@@ -6523,7 +6617,7 @@
         </p:nvSpPr>
         <p:spPr>
           <a:xfrm>
-            <a:off x="731520" y="1051560"/>
+            <a:off x="731520" y="1097280"/>
             <a:ext cx="10058400" cy="457200"/>
           </a:xfrm>
           <a:prstGeom prst="rect">
@@ -6589,6 +6683,7 @@
           <a:lstStyle/>
           <a:p>
             <a:pPr algn="ctr"/>
+            <a:endParaRPr/>
           </a:p>
         </p:txBody>
       </p:sp>
@@ -6700,6 +6795,7 @@
           <a:lstStyle/>
           <a:p>
             <a:pPr algn="ctr"/>
+            <a:endParaRPr/>
           </a:p>
         </p:txBody>
       </p:sp>
@@ -6811,6 +6907,7 @@
           <a:lstStyle/>
           <a:p>
             <a:pPr algn="ctr"/>
+            <a:endParaRPr/>
           </a:p>
         </p:txBody>
       </p:sp>
@@ -6922,6 +7019,7 @@
           <a:lstStyle/>
           <a:p>
             <a:pPr algn="ctr"/>
+            <a:endParaRPr/>
           </a:p>
         </p:txBody>
       </p:sp>
@@ -7033,6 +7131,7 @@
           <a:lstStyle/>
           <a:p>
             <a:pPr algn="ctr"/>
+            <a:endParaRPr/>
           </a:p>
         </p:txBody>
       </p:sp>
@@ -7170,7 +7269,6 @@
                 </a:solidFill>
                 <a:latin typeface="Calibri"/>
               </a:defRPr>
-              <a:buChar char="•"/>
             </a:pPr>
             <a:r>
               <a:t>Ad characteristics: funny, celebrity, patriotic, danger, animals, use_sex, show_product_quickly</a:t>
@@ -7187,7 +7285,6 @@
                 </a:solidFill>
                 <a:latin typeface="Calibri"/>
               </a:defRPr>
-              <a:buChar char="•"/>
             </a:pPr>
             <a:r>
               <a:t>YouTube engagement: views, likes, dislikes, comments, favorites</a:t>
@@ -7204,7 +7301,6 @@
                 </a:solidFill>
                 <a:latin typeface="Calibri"/>
               </a:defRPr>
-              <a:buChar char="•"/>
             </a:pPr>
             <a:r>
               <a:t>Video metadata: title, description, publish date, channel, thumbnail</a:t>
@@ -7221,7 +7317,6 @@
                 </a:solidFill>
                 <a:latin typeface="Calibri"/>
               </a:defRPr>
-              <a:buChar char="•"/>
             </a:pPr>
             <a:r>
               <a:t>Source: FiveThirtyEight staffers hand-coded every ad from video</a:t>
@@ -7262,7 +7357,7 @@
 </file>
 
 <file path=ppt/slides/slide5.xml><?xml version="1.0" encoding="utf-8"?>
-<p:sld xmlns:a="http://schemas.openxmlformats.org/drawingml/2006/main" xmlns:p="http://schemas.openxmlformats.org/presentationml/2006/main" xmlns:r="http://schemas.openxmlformats.org/officeDocument/2006/relationships">
+<p:sld xmlns:a="http://schemas.openxmlformats.org/drawingml/2006/main" xmlns:r="http://schemas.openxmlformats.org/officeDocument/2006/relationships" xmlns:p="http://schemas.openxmlformats.org/presentationml/2006/main">
   <p:cSld>
     <p:bg>
       <p:bgPr>
@@ -7278,7 +7373,14 @@
         <p:cNvGrpSpPr/>
         <p:nvPr/>
       </p:nvGrpSpPr>
-      <p:grpSpPr/>
+      <p:grpSpPr>
+        <a:xfrm>
+          <a:off x="0" y="0"/>
+          <a:ext cx="0" cy="0"/>
+          <a:chOff x="0" y="0"/>
+          <a:chExt cx="0" cy="0"/>
+        </a:xfrm>
+      </p:grpSpPr>
       <p:sp>
         <p:nvSpPr>
           <p:cNvPr id="2" name="Rectangle 1"/>
@@ -7319,6 +7421,7 @@
           <a:lstStyle/>
           <a:p>
             <a:pPr algn="ctr"/>
+            <a:endParaRPr/>
           </a:p>
         </p:txBody>
       </p:sp>
@@ -7331,7 +7434,7 @@
         <p:spPr>
           <a:xfrm>
             <a:off x="731520" y="457200"/>
-            <a:ext cx="10058400" cy="548640"/>
+            <a:ext cx="10058400" cy="731520"/>
           </a:xfrm>
           <a:prstGeom prst="rect">
             <a:avLst/>
@@ -7364,7 +7467,7 @@
         </p:nvSpPr>
         <p:spPr>
           <a:xfrm>
-            <a:off x="731520" y="1051560"/>
+            <a:off x="731520" y="1097280"/>
             <a:ext cx="10058400" cy="457200"/>
           </a:xfrm>
           <a:prstGeom prst="rect">
@@ -7593,7 +7696,7 @@
 </file>
 
 <file path=ppt/slides/slide6.xml><?xml version="1.0" encoding="utf-8"?>
-<p:sld xmlns:a="http://schemas.openxmlformats.org/drawingml/2006/main" xmlns:p="http://schemas.openxmlformats.org/presentationml/2006/main" xmlns:r="http://schemas.openxmlformats.org/officeDocument/2006/relationships">
+<p:sld xmlns:a="http://schemas.openxmlformats.org/drawingml/2006/main" xmlns:r="http://schemas.openxmlformats.org/officeDocument/2006/relationships" xmlns:p="http://schemas.openxmlformats.org/presentationml/2006/main">
   <p:cSld>
     <p:bg>
       <p:bgPr>
@@ -7609,7 +7712,14 @@
         <p:cNvGrpSpPr/>
         <p:nvPr/>
       </p:nvGrpSpPr>
-      <p:grpSpPr/>
+      <p:grpSpPr>
+        <a:xfrm>
+          <a:off x="0" y="0"/>
+          <a:ext cx="0" cy="0"/>
+          <a:chOff x="0" y="0"/>
+          <a:chExt cx="0" cy="0"/>
+        </a:xfrm>
+      </p:grpSpPr>
       <p:sp>
         <p:nvSpPr>
           <p:cNvPr id="2" name="Rectangle 1"/>
@@ -7650,6 +7760,7 @@
           <a:lstStyle/>
           <a:p>
             <a:pPr algn="ctr"/>
+            <a:endParaRPr/>
           </a:p>
         </p:txBody>
       </p:sp>
@@ -7662,7 +7773,7 @@
         <p:spPr>
           <a:xfrm>
             <a:off x="731520" y="457200"/>
-            <a:ext cx="10058400" cy="548640"/>
+            <a:ext cx="10058400" cy="731520"/>
           </a:xfrm>
           <a:prstGeom prst="rect">
             <a:avLst/>
@@ -7695,7 +7806,7 @@
         </p:nvSpPr>
         <p:spPr>
           <a:xfrm>
-            <a:off x="731520" y="1051560"/>
+            <a:off x="731520" y="1097280"/>
             <a:ext cx="10058400" cy="457200"/>
           </a:xfrm>
           <a:prstGeom prst="rect">
@@ -7785,6 +7896,7 @@
           <a:lstStyle/>
           <a:p>
             <a:pPr algn="ctr"/>
+            <a:endParaRPr/>
           </a:p>
         </p:txBody>
       </p:sp>
@@ -7828,6 +7940,7 @@
           <a:lstStyle/>
           <a:p>
             <a:pPr algn="ctr"/>
+            <a:endParaRPr/>
           </a:p>
         </p:txBody>
       </p:sp>
@@ -7897,7 +8010,6 @@
                 </a:solidFill>
                 <a:latin typeface="Calibri"/>
               </a:defRPr>
-              <a:buChar char="•"/>
             </a:pPr>
             <a:r>
               <a:t>Show Product Quickly: +70% views lift</a:t>
@@ -7914,7 +8026,6 @@
                 </a:solidFill>
                 <a:latin typeface="Calibri"/>
               </a:defRPr>
-              <a:buChar char="•"/>
             </a:pPr>
             <a:r>
               <a:t>Patriotic themes: +33% lift</a:t>
@@ -7931,7 +8042,6 @@
                 </a:solidFill>
                 <a:latin typeface="Calibri"/>
               </a:defRPr>
-              <a:buChar char="•"/>
             </a:pPr>
             <a:r>
               <a:t>Funny ads: +12% lift</a:t>
@@ -7948,7 +8058,6 @@
                 </a:solidFill>
                 <a:latin typeface="Calibri"/>
               </a:defRPr>
-              <a:buChar char="•"/>
             </a:pPr>
             <a:r>
               <a:t>Celebrity ads actually get fewer views (-54%)</a:t>
@@ -7965,7 +8074,7 @@
 </file>
 
 <file path=ppt/slides/slide7.xml><?xml version="1.0" encoding="utf-8"?>
-<p:sld xmlns:a="http://schemas.openxmlformats.org/drawingml/2006/main" xmlns:p="http://schemas.openxmlformats.org/presentationml/2006/main" xmlns:r="http://schemas.openxmlformats.org/officeDocument/2006/relationships">
+<p:sld xmlns:a="http://schemas.openxmlformats.org/drawingml/2006/main" xmlns:r="http://schemas.openxmlformats.org/officeDocument/2006/relationships" xmlns:p="http://schemas.openxmlformats.org/presentationml/2006/main">
   <p:cSld>
     <p:bg>
       <p:bgPr>
@@ -7981,7 +8090,14 @@
         <p:cNvGrpSpPr/>
         <p:nvPr/>
       </p:nvGrpSpPr>
-      <p:grpSpPr/>
+      <p:grpSpPr>
+        <a:xfrm>
+          <a:off x="0" y="0"/>
+          <a:ext cx="0" cy="0"/>
+          <a:chOff x="0" y="0"/>
+          <a:chExt cx="0" cy="0"/>
+        </a:xfrm>
+      </p:grpSpPr>
       <p:sp>
         <p:nvSpPr>
           <p:cNvPr id="2" name="Rectangle 1"/>
@@ -8022,6 +8138,7 @@
           <a:lstStyle/>
           <a:p>
             <a:pPr algn="ctr"/>
+            <a:endParaRPr/>
           </a:p>
         </p:txBody>
       </p:sp>
@@ -8034,7 +8151,7 @@
         <p:spPr>
           <a:xfrm>
             <a:off x="731520" y="457200"/>
-            <a:ext cx="10058400" cy="548640"/>
+            <a:ext cx="10058400" cy="731520"/>
           </a:xfrm>
           <a:prstGeom prst="rect">
             <a:avLst/>
@@ -8067,7 +8184,7 @@
         </p:nvSpPr>
         <p:spPr>
           <a:xfrm>
-            <a:off x="731520" y="1051560"/>
+            <a:off x="731520" y="1097280"/>
             <a:ext cx="10058400" cy="457200"/>
           </a:xfrm>
           <a:prstGeom prst="rect">
@@ -8157,6 +8274,7 @@
           <a:lstStyle/>
           <a:p>
             <a:pPr algn="ctr"/>
+            <a:endParaRPr/>
           </a:p>
         </p:txBody>
       </p:sp>
@@ -8200,6 +8318,7 @@
           <a:lstStyle/>
           <a:p>
             <a:pPr algn="ctr"/>
+            <a:endParaRPr/>
           </a:p>
         </p:txBody>
       </p:sp>
@@ -8303,7 +8422,6 @@
                 </a:solidFill>
                 <a:latin typeface="Calibri"/>
               </a:defRPr>
-              <a:buChar char="•"/>
             </a:pPr>
             <a:r>
               <a:t>Topic 1: Hyundai campaigns (hyundai, bowl, super, world)</a:t>
@@ -8320,7 +8438,6 @@
                 </a:solidFill>
                 <a:latin typeface="Calibri"/>
               </a:defRPr>
-              <a:buChar char="•"/>
             </a:pPr>
             <a:r>
               <a:t>Topic 2: Bud Light / Budweiser (commercial, light, bud, budweiser)</a:t>
@@ -8337,7 +8454,6 @@
                 </a:solidFill>
                 <a:latin typeface="Calibri"/>
               </a:defRPr>
-              <a:buChar char="•"/>
             </a:pPr>
             <a:r>
               <a:t>Topic 3: Recent Super Bowl (bowl, super, commercial, 2020)</a:t>
@@ -8354,7 +8470,6 @@
                 </a:solidFill>
                 <a:latin typeface="Calibri"/>
               </a:defRPr>
-              <a:buChar char="•"/>
             </a:pPr>
             <a:r>
               <a:t>Topic 4: Doritos / snack brands (doritos, chip, crash, super)</a:t>
@@ -8371,7 +8486,6 @@
                 </a:solidFill>
                 <a:latin typeface="Calibri"/>
               </a:defRPr>
-              <a:buChar char="•"/>
             </a:pPr>
             <a:r>
               <a:t>Topic 5: NFL / game themes (nfl, game, football, team)</a:t>
@@ -8422,7 +8536,7 @@
 </file>
 
 <file path=ppt/slides/slide8.xml><?xml version="1.0" encoding="utf-8"?>
-<p:sld xmlns:a="http://schemas.openxmlformats.org/drawingml/2006/main" xmlns:p="http://schemas.openxmlformats.org/presentationml/2006/main" xmlns:r="http://schemas.openxmlformats.org/officeDocument/2006/relationships">
+<p:sld xmlns:a="http://schemas.openxmlformats.org/drawingml/2006/main" xmlns:r="http://schemas.openxmlformats.org/officeDocument/2006/relationships" xmlns:p="http://schemas.openxmlformats.org/presentationml/2006/main">
   <p:cSld>
     <p:bg>
       <p:bgPr>
@@ -8438,7 +8552,14 @@
         <p:cNvGrpSpPr/>
         <p:nvPr/>
       </p:nvGrpSpPr>
-      <p:grpSpPr/>
+      <p:grpSpPr>
+        <a:xfrm>
+          <a:off x="0" y="0"/>
+          <a:ext cx="0" cy="0"/>
+          <a:chOff x="0" y="0"/>
+          <a:chExt cx="0" cy="0"/>
+        </a:xfrm>
+      </p:grpSpPr>
       <p:sp>
         <p:nvSpPr>
           <p:cNvPr id="2" name="Rectangle 1"/>
@@ -8479,6 +8600,7 @@
           <a:lstStyle/>
           <a:p>
             <a:pPr algn="ctr"/>
+            <a:endParaRPr/>
           </a:p>
         </p:txBody>
       </p:sp>
@@ -8491,7 +8613,7 @@
         <p:spPr>
           <a:xfrm>
             <a:off x="731520" y="457200"/>
-            <a:ext cx="10058400" cy="548640"/>
+            <a:ext cx="10058400" cy="731520"/>
           </a:xfrm>
           <a:prstGeom prst="rect">
             <a:avLst/>
@@ -8524,7 +8646,7 @@
         </p:nvSpPr>
         <p:spPr>
           <a:xfrm>
-            <a:off x="731520" y="1051560"/>
+            <a:off x="731520" y="1097280"/>
             <a:ext cx="10058400" cy="457200"/>
           </a:xfrm>
           <a:prstGeom prst="rect">
@@ -8590,6 +8712,7 @@
           <a:lstStyle/>
           <a:p>
             <a:pPr algn="ctr"/>
+            <a:endParaRPr/>
           </a:p>
         </p:txBody>
       </p:sp>
@@ -8633,6 +8756,7 @@
           <a:lstStyle/>
           <a:p>
             <a:pPr algn="ctr"/>
+            <a:endParaRPr/>
           </a:p>
         </p:txBody>
       </p:sp>
@@ -8752,6 +8876,7 @@
           <a:lstStyle/>
           <a:p>
             <a:pPr algn="ctr"/>
+            <a:endParaRPr/>
           </a:p>
         </p:txBody>
       </p:sp>
@@ -8829,6 +8954,7 @@
           <a:lstStyle/>
           <a:p>
             <a:pPr algn="ctr"/>
+            <a:endParaRPr/>
           </a:p>
         </p:txBody>
       </p:sp>
@@ -8872,6 +8998,7 @@
           <a:lstStyle/>
           <a:p>
             <a:pPr algn="ctr"/>
+            <a:endParaRPr/>
           </a:p>
         </p:txBody>
       </p:sp>
@@ -8991,6 +9118,7 @@
           <a:lstStyle/>
           <a:p>
             <a:pPr algn="ctr"/>
+            <a:endParaRPr/>
           </a:p>
         </p:txBody>
       </p:sp>
@@ -9068,6 +9196,7 @@
           <a:lstStyle/>
           <a:p>
             <a:pPr algn="ctr"/>
+            <a:endParaRPr/>
           </a:p>
         </p:txBody>
       </p:sp>
@@ -9111,6 +9240,7 @@
           <a:lstStyle/>
           <a:p>
             <a:pPr algn="ctr"/>
+            <a:endParaRPr/>
           </a:p>
         </p:txBody>
       </p:sp>
@@ -9230,6 +9360,7 @@
           <a:lstStyle/>
           <a:p>
             <a:pPr algn="ctr"/>
+            <a:endParaRPr/>
           </a:p>
         </p:txBody>
       </p:sp>
@@ -9276,7 +9407,7 @@
 </file>
 
 <file path=ppt/slides/slide9.xml><?xml version="1.0" encoding="utf-8"?>
-<p:sld xmlns:a="http://schemas.openxmlformats.org/drawingml/2006/main" xmlns:p="http://schemas.openxmlformats.org/presentationml/2006/main" xmlns:r="http://schemas.openxmlformats.org/officeDocument/2006/relationships">
+<p:sld xmlns:a="http://schemas.openxmlformats.org/drawingml/2006/main" xmlns:r="http://schemas.openxmlformats.org/officeDocument/2006/relationships" xmlns:p="http://schemas.openxmlformats.org/presentationml/2006/main">
   <p:cSld>
     <p:bg>
       <p:bgPr>
@@ -9292,7 +9423,14 @@
         <p:cNvGrpSpPr/>
         <p:nvPr/>
       </p:nvGrpSpPr>
-      <p:grpSpPr/>
+      <p:grpSpPr>
+        <a:xfrm>
+          <a:off x="0" y="0"/>
+          <a:ext cx="0" cy="0"/>
+          <a:chOff x="0" y="0"/>
+          <a:chExt cx="0" cy="0"/>
+        </a:xfrm>
+      </p:grpSpPr>
       <p:sp>
         <p:nvSpPr>
           <p:cNvPr id="2" name="Rectangle 1"/>
@@ -9333,6 +9471,7 @@
           <a:lstStyle/>
           <a:p>
             <a:pPr algn="ctr"/>
+            <a:endParaRPr/>
           </a:p>
         </p:txBody>
       </p:sp>
@@ -9410,6 +9549,7 @@
           <a:lstStyle/>
           <a:p>
             <a:pPr algn="ctr"/>
+            <a:endParaRPr/>
           </a:p>
         </p:txBody>
       </p:sp>
@@ -9521,6 +9661,7 @@
           <a:lstStyle/>
           <a:p>
             <a:pPr algn="ctr"/>
+            <a:endParaRPr/>
           </a:p>
         </p:txBody>
       </p:sp>
@@ -9632,6 +9773,7 @@
           <a:lstStyle/>
           <a:p>
             <a:pPr algn="ctr"/>
+            <a:endParaRPr/>
           </a:p>
         </p:txBody>
       </p:sp>
@@ -9743,6 +9885,7 @@
           <a:lstStyle/>
           <a:p>
             <a:pPr algn="ctr"/>
+            <a:endParaRPr/>
           </a:p>
         </p:txBody>
       </p:sp>
@@ -9854,6 +9997,7 @@
           <a:lstStyle/>
           <a:p>
             <a:pPr algn="ctr"/>
+            <a:endParaRPr/>
           </a:p>
         </p:txBody>
       </p:sp>

</xml_diff>